<commit_message>
refactor(currency&team): convert all tariff protection metrics to Indian Rupees (INR) and add IIPE college to Deepak R, remove roll number
</commit_message>
<xml_diff>
--- a/docs/EcoCast_AI_Yuva_Yodha_Presentation.pptx
+++ b/docs/EcoCast_AI_Yuva_Yodha_Presentation.pptx
@@ -3324,7 +3324,7 @@
               </a:defRPr>
             </a:pPr>
             <a:r>
-              <a:t>• Deepak R (Team Lead) — Systems Architect &amp; Edge Developer | Full-Stack IoT, 3D Digital Twin, Modbus-TCP Ingestion</a:t>
+              <a:t>• Deepak R (Team Lead) — Systems Architect &amp; Edge Developer | Indian Institute of Petroleum and Energy (IIPE)</a:t>
             </a:r>
           </a:p>
           <a:p>
@@ -3339,7 +3339,7 @@
               </a:defRPr>
             </a:pPr>
             <a:r>
-              <a:t>• Saranya Dutta (Team Member) — Chemical Process Engineer | Roll: 23CH10028 | saranyadutta@iipe.ac.in | Thermodynamics, Energy Balances &amp; EU CBAM/BEE Modeling</a:t>
+              <a:t>• Saranya Dutta (Team Member) — Chemical Process Engineer | saranyadutta@iipe.ac.in | Indian Institute of Petroleum and Energy (IIPE)</a:t>
             </a:r>
           </a:p>
         </p:txBody>
@@ -4906,6 +4906,21 @@
               </a:defRPr>
             </a:pPr>
             <a:r>
+              <a:t>•    • Indian Institute of Petroleum and Energy (IIPE).</a:t>
+            </a:r>
+          </a:p>
+          <a:p>
+            <a:pPr>
+              <a:spcBef>
+                <a:spcPts val="500"/>
+              </a:spcBef>
+              <a:defRPr sz="1100">
+                <a:solidFill>
+                  <a:srgbClr val="475569"/>
+                </a:solidFill>
+              </a:defRPr>
+            </a:pPr>
+            <a:r>
               <a:t>•    • Systems architecture, full-stack edge computing, and Three.js 3D WebGL digital twin engineering.</a:t>
             </a:r>
           </a:p>
@@ -4951,22 +4966,7 @@
               </a:defRPr>
             </a:pPr>
             <a:r>
-              <a:t>•    • Chemical Engineering, Indian Institute of Petroleum and Energy (IIPE).</a:t>
-            </a:r>
-          </a:p>
-          <a:p>
-            <a:pPr>
-              <a:spcBef>
-                <a:spcPts val="500"/>
-              </a:spcBef>
-              <a:defRPr sz="1100">
-                <a:solidFill>
-                  <a:srgbClr val="475569"/>
-                </a:solidFill>
-              </a:defRPr>
-            </a:pPr>
-            <a:r>
-              <a:t>•    • Student Roll No: 23CH10028 | saranyadutta@iipe.ac.in</a:t>
+              <a:t>•    • Chemical Engineering, Indian Institute of Petroleum and Energy (IIPE) | saranyadutta@iipe.ac.in</a:t>
             </a:r>
           </a:p>
           <a:p>
@@ -5918,7 +5918,7 @@
               </a:defRPr>
             </a:pPr>
             <a:r>
-              <a:t>•  Direct Penalty Risk: Without verifiable carbon audits, Indian MSMEs face up to €79.68/tCO2 in tariffs (~₹7,450 per tonne).</a:t>
+              <a:t>•  Direct Penalty Risk: Without verifiable carbon audits, Indian MSMEs face cross-border carbon tariffs of ₹7,450 per tonne (~₹22.5 Lakhs/year).</a:t>
             </a:r>
           </a:p>
           <a:p>

</xml_diff>